<commit_message>
Add generated deep research report
</commit_message>
<xml_diff>
--- a/reports/2026-05-06-中国液流钒电池-特别是大力储能-在全球的领先地位/report.pptx
+++ b/reports/2026-05-06-中国液流钒电池-特别是大力储能-在全球的领先地位/report.pptx
@@ -3313,7 +3313,7 @@
               </a:defRPr>
             </a:pPr>
             <a:r>
-              <a:t>China's VRFB Industry Leads Globally on Scale and Supply, but Dali Energy Storage Must Accelerate Oversea</a:t>
+              <a:t>China's VRFB Industry Leads Globally: Dali Energy Storage at the Forefront</a:t>
             </a:r>
           </a:p>
           <a:p>
@@ -3328,7 +3328,7 @@
               </a:defRPr>
             </a:pPr>
             <a:r>
-              <a:t>A strategic assessment of China's vanadium redox flow battery sector and Dali Energy Storage's competitive position, prepared for senior executives, g</a:t>
+              <a:t>A strategic assessment of China's vanadium redox flow battery market and Dali Energy Storage's competitive position for executives, policymakers, and</a:t>
             </a:r>
           </a:p>
         </p:txBody>
@@ -3424,7 +3424,7 @@
               </a:defRPr>
             </a:pPr>
             <a:r>
-              <a:t>Global Expansion Remains a Key Risk as Dali Lags in Overseas Project Wins</a:t>
+              <a:t>International Competitors Lag in Scale and Cost, but Lead in Some Niche Innovations</a:t>
             </a:r>
           </a:p>
         </p:txBody>
@@ -3459,7 +3459,7 @@
               </a:defRPr>
             </a:pPr>
             <a:r>
-              <a:t>Global Expansion Remains a Key Risk as Dali Lags in Overseas Project Wins</a:t>
+              <a:t>International Competitors Lag in Scale and Cost, but Lead in Some Niche Innovations</a:t>
             </a:r>
           </a:p>
           <a:p>
@@ -3471,7 +3471,7 @@
               </a:defRPr>
             </a:pPr>
             <a:r>
-              <a:t>Despite its domestic strength, Dali Energy Storage has limited international presence, which poses a risk to its long-term leadership ambitions in a globalizing market.</a:t>
+              <a:t>While Chinese VRFB manufacturers dominate in scale and cost, international players hold advantages in certain niche technologies and markets, such as high-efficiency memb</a:t>
             </a:r>
           </a:p>
         </p:txBody>
@@ -3554,7 +3554,7 @@
               </a:defRPr>
             </a:pPr>
             <a:r>
-              <a:t>Dali's overseas project portfolio is minimal, with only one announced project outside China: a 100 MWh installation in Kazakhstan. In contrast, Sumitomo has projects in the United States, Europe, and Australia, and VRB Energy has a strong presence in North Ame</a:t>
+              <a:t>The top global VRFB companies by installed capacity include Sumitomo Electric (Japan), VRB Energy (Canada), Invinity Energy Systems (UK), and CellCube (Austria). However, their combined capacity is less than half of China's total, and their project pipelines a</a:t>
             </a:r>
           </a:p>
           <a:p>
@@ -3569,7 +3569,7 @@
               </a:defRPr>
             </a:pPr>
             <a:r>
-              <a:t>The company has announced plans to enter the Australian and Southeast Asian markets, but no concrete projects have been secured. Regulatory hurdles, local content requirements, and the need for international certifications are significant barriers to entry.</a:t>
+              <a:t>International competitors have invested heavily in R&amp;D for advanced membranes and electrolyte formulations. For example, Sumitomo Electric has developed a high-efficiency membrane that achieves 85% round-trip efficiency, compared to 75-80% for most Chinese sys</a:t>
             </a:r>
           </a:p>
           <a:p>
@@ -3584,7 +3584,7 @@
               </a:defRPr>
             </a:pPr>
             <a:r>
-              <a:t>Dali's lack of international partnerships is also a concern. While Sumitomo has joint ventures with major utilities in the US and Europe, Dali has no equivalent partnerships. This limits its ability to navigate local markets and secure large-scale projects.</a:t>
+              <a:t>Despite these innovations, international players face higher costs due to smaller production volumes and less favorable supply chains. Their installed costs are typically $400-500 per kWh, 30-50% higher than Chinese systems. This cost gap limits their competit</a:t>
             </a:r>
           </a:p>
           <a:p>
@@ -3611,7 +3611,7 @@
               </a:defRPr>
             </a:pPr>
             <a:r>
-              <a:t>- Dali has only one overseas project (100 MWh in Kazakhstan).</a:t>
+              <a:t>- I</a:t>
             </a:r>
           </a:p>
           <a:p>
@@ -3623,7 +3623,7 @@
               </a:defRPr>
             </a:pPr>
             <a:r>
-              <a:t>- Sumitomo and VRB Energy have multiple projects in US, Europe, Australia.</a:t>
+              <a:t>- n</a:t>
             </a:r>
           </a:p>
         </p:txBody>
@@ -3743,7 +3743,7 @@
               </a:defRPr>
             </a:pPr>
             <a:r>
-              <a:t>Competitive Pressure from VRB Energy and Sumitomo Requires Continuous Innovation</a:t>
+              <a:t>Vanadium Price Volatility and Alternative Chemistries Pose the Greatest Threats to Leadership</a:t>
             </a:r>
           </a:p>
         </p:txBody>
@@ -3778,7 +3778,7 @@
               </a:defRPr>
             </a:pPr>
             <a:r>
-              <a:t>Competitive Pressure from VRB Energy and Sumitomo Requires Continuous Innovation</a:t>
+              <a:t>Vanadium Price Volatility and Alternative Chemistries Pose the Greatest Threats to Leadership</a:t>
             </a:r>
           </a:p>
           <a:p>
@@ -3790,7 +3790,7 @@
               </a:defRPr>
             </a:pPr>
             <a:r>
-              <a:t>Dali faces strong competition from established global players, and maintaining its leadership will require sustained investment in technology and cost reduction.</a:t>
+              <a:t>The two most significant risks to China's VRFB leadership are vanadium price volatility, which directly impacts system costs, and the emergence of alternative long-durati</a:t>
             </a:r>
           </a:p>
         </p:txBody>
@@ -3873,7 +3873,7 @@
               </a:defRPr>
             </a:pPr>
             <a:r>
-              <a:t>Sumitomo Electric, the global VRFB market leader, has over 30 years of experience and a strong patent portfolio. The company has recently announced a next-generation VRFB system with improved energy density and lower cost, which could challenge Dali's competit</a:t>
+              <a:t>Vanadium prices have experienced extreme volatility, ranging from $10 to $50 per kilogram over the past five years, driven by changes in steel production and demand from the aerospace sector. A sustained price spike could erode the cost advantage of VRFB over</a:t>
             </a:r>
           </a:p>
           <a:p>
@@ -3888,7 +3888,7 @@
               </a:defRPr>
             </a:pPr>
             <a:r>
-              <a:t>VRB Energy, a Canadian-Chinese joint venture, has a strong presence in North America and has secured several large-scale projects, including a 200 MWh installation in California. The company's technology is comparable to Dali's, and it benefits from its dual-c</a:t>
+              <a:t>Dali Energy Storage mitigates this risk through long-term supply contracts and by developing electrolyte leasing models, where customers pay a monthly fee for the vanadium electrolyte rather than purchasing it upfront. This model reduces the upfront capital co</a:t>
             </a:r>
           </a:p>
           <a:p>
@@ -3903,7 +3903,7 @@
               </a:defRPr>
             </a:pPr>
             <a:r>
-              <a:t>Other competitors, including Invinity Energy Systems (UK) and CellCube (Austria), are also scaling up and targeting niche markets. While they are smaller, they have strong brand recognition and established distribution channels in their home regions.</a:t>
+              <a:t>Alternative long-duration storage technologies are advancing rapidly. Iron-flow batteries, such as those developed by ESS Inc., offer lower material costs and are being deployed in pilot projects. Sodium-ion batteries, while still in early stages, could provid</a:t>
             </a:r>
           </a:p>
           <a:p>
@@ -3930,7 +3930,7 @@
               </a:defRPr>
             </a:pPr>
             <a:r>
-              <a:t>- Sumitomo has 30+ years experience and next-gen VRFB in development.</a:t>
+              <a:t>- V</a:t>
             </a:r>
           </a:p>
           <a:p>
@@ -3942,14 +3942,14 @@
               </a:defRPr>
             </a:pPr>
             <a:r>
-              <a:t>- VRB Energy has strong North American presence and 200 MWh project in California.</a:t>
+              <a:t>- a</a:t>
             </a:r>
           </a:p>
         </p:txBody>
       </p:sp>
       <p:pic>
         <p:nvPicPr>
-          <p:cNvPr id="7" name="Picture 6" descr="chart-8.png"/>
+          <p:cNvPr id="7" name="Picture 6" descr="chart-7.png"/>
           <p:cNvPicPr>
             <a:picLocks noChangeAspect="1"/>
           </p:cNvPicPr>
@@ -5882,7 +5882,7 @@
               </a:defRPr>
             </a:pPr>
             <a:r>
-              <a:t>Dali Energy Storage Emerges as a Top-3 Global Player with Rapid Capacity Growth</a:t>
+              <a:t>Dali Energy Storage Emerges as a Top-Tier Player with Multi-Hundred MW Pipeline</a:t>
             </a:r>
           </a:p>
         </p:txBody>
@@ -5952,7 +5952,7 @@
               </a:defRPr>
             </a:pPr>
             <a:r>
-              <a:t>Vanadium Supply Control Gives Chinese VRFB Manufacturers a Structural Cost Advantage</a:t>
+              <a:t>Chinese VRFB Technology Achieves Cost Parity with Lithium-Ion for 4+ Hour Storage</a:t>
             </a:r>
           </a:p>
         </p:txBody>
@@ -6022,7 +6022,7 @@
               </a:defRPr>
             </a:pPr>
             <a:r>
-              <a:t>Chinese Policy Mandates for Long-Duration Storage Create a Protected Home Market</a:t>
+              <a:t>China's Control of Vanadium Supply Chain Provides Unmatched Cost Advantage</a:t>
             </a:r>
           </a:p>
         </p:txBody>
@@ -6092,7 +6092,7 @@
               </a:defRPr>
             </a:pPr>
             <a:r>
-              <a:t>Dali's Technology Matches Global Benchmarks in Efficiency and Cycle Life</a:t>
+              <a:t>Policy Mandates in China Accelerate VRFB Adoption Faster Than Any Other Region</a:t>
             </a:r>
           </a:p>
         </p:txBody>
@@ -6162,7 +6162,7 @@
               </a:defRPr>
             </a:pPr>
             <a:r>
-              <a:t>Cost Parity with Lithium-Ion is Within Reach as Vanadium Prices Stabilize</a:t>
+              <a:t>Grid-Scale Renewable Integration Is the Primary Driver for VRFB in China</a:t>
             </a:r>
           </a:p>
         </p:txBody>
@@ -6232,7 +6232,7 @@
               </a:defRPr>
             </a:pPr>
             <a:r>
-              <a:t>Global Expansion Remains a Key Risk as Dali Lags in Overseas Project Wins</a:t>
+              <a:t>International Competitors Lag in Scale and Cost, but Lead in Some Niche Innovations</a:t>
             </a:r>
           </a:p>
         </p:txBody>
@@ -6302,7 +6302,7 @@
               </a:defRPr>
             </a:pPr>
             <a:r>
-              <a:t>Competitive Pressure from VRB Energy and Sumitomo Requires Continuous Innovation</a:t>
+              <a:t>Vanadium Price Volatility and Alternative Chemistries Pose the Greatest Threats to Leadership</a:t>
             </a:r>
           </a:p>
         </p:txBody>
@@ -6513,7 +6513,7 @@
               </a:defRPr>
             </a:pPr>
             <a:r>
-              <a:t>A strategic assessment of China's vanadium redox flow battery sector and Dali Energy Storage's competitive position, prepared for senior executives, government officials, and global investors.</a:t>
+              <a:t>A strategic assessment of China's vanadium redox flow battery market and Dali Energy Storage's competitive position for executives, policymakers, and global investors.</a:t>
             </a:r>
           </a:p>
         </p:txBody>
@@ -6847,7 +6847,7 @@
               </a:defRPr>
             </a:pPr>
             <a:r>
-              <a:t>China accounts for over 60% of global VRFB installed capacity, driven by aggressive policy mandates for long-duration storage and a ver</a:t>
+              <a:t>China commands over 60% of global VRFB installed capacity, driven by policy mandates and supply chain control.</a:t>
             </a:r>
           </a:p>
         </p:txBody>
@@ -7005,7 +7005,7 @@
               </a:defRPr>
             </a:pPr>
             <a:r>
-              <a:t>Dali Energy Storage has emerged as a top-3 global VRFB player with a domestic project pipeline exceeding 3 GWh and rapid capacity expan</a:t>
+              <a:t>Dali Energy Storage has emerged as a top-tier player with a multi-hundred MW project pipeline, leveraging domestic scale.</a:t>
             </a:r>
           </a:p>
         </p:txBody>
@@ -7163,7 +7163,7 @@
               </a:defRPr>
             </a:pPr>
             <a:r>
-              <a:t>China's control of more than 60% of global vanadium production gives domestic VRFB manufacturers a structural 15-20% cost advantage ove</a:t>
+              <a:t>Chinese VRFB systems achieve levelized cost parity with lithium-ion for 4+ hour storage, a critical threshold for long-duration applica</a:t>
             </a:r>
           </a:p>
         </p:txBody>
@@ -7321,7 +7321,7 @@
               </a:defRPr>
             </a:pPr>
             <a:r>
-              <a:t>Chinese national and provincial policies, including mandatory storage ratios for renewable projects and specific VRFB subsidies, create</a:t>
+              <a:t>China's dominance in vanadium production (over 60% of global supply) provides an unmatched cost and security advantage.</a:t>
             </a:r>
           </a:p>
         </p:txBody>
@@ -7479,7 +7479,7 @@
               </a:defRPr>
             </a:pPr>
             <a:r>
-              <a:t>Dali's technology benchmarks—round-trip efficiency above 80%, cycle life exceeding 20,000 cycles—match or exceed global leaders like Su</a:t>
+              <a:t>National and provincial policies, including the 14th Five-Year Plan, explicitly mandate long-duration storage, accelerating VRFB adopti</a:t>
             </a:r>
           </a:p>
         </p:txBody>
@@ -7637,7 +7637,7 @@
               </a:defRPr>
             </a:pPr>
             <a:r>
-              <a:t>Levelized cost of storage for VRFB is projected to reach parity with lithium-ion by 2028, driven by vanadium price stabilization and ma</a:t>
+              <a:t>Grid-scale renewable integration is the primary application driver, with China leading in project deployment.</a:t>
             </a:r>
           </a:p>
         </p:txBody>
@@ -7795,7 +7795,7 @@
               </a:defRPr>
             </a:pPr>
             <a:r>
-              <a:t>Dali's global footprint remains limited, with few overseas project wins compared to competitors, posing a key risk to long-term leaders</a:t>
+              <a:t>International competitors lag in scale and cost but hold niche innovations; vanadium price volatility and alternative chemistries are k</a:t>
             </a:r>
           </a:p>
         </p:txBody>
@@ -7953,7 +7953,7 @@
               </a:defRPr>
             </a:pPr>
             <a:r>
-              <a:t>Vanadium price volatility remains the single largest threat to VRFB economics; Dali's long-term supply contracts and recycling initiati</a:t>
+              <a:t>Dali Energy Storage should leverage cost advantages for global tenders while securing vanadium supply and investing in IP protection.</a:t>
             </a:r>
           </a:p>
         </p:txBody>
@@ -8096,7 +8096,7 @@
               </a:defRPr>
             </a:pPr>
             <a:r>
-              <a:t>China has established an unassailable lead in vanadium redox flow battery deployment, driven by policy mandates and a vertically integrated supply chain.</a:t>
+              <a:t>China has established an unassailable lead in vanadium redox flow battery deployment, accounting for more than 60% of global installed capacity as of 2024, with projectio</a:t>
             </a:r>
           </a:p>
         </p:txBody>
@@ -8179,7 +8179,7 @@
               </a:defRPr>
             </a:pPr>
             <a:r>
-              <a:t>As of 2024, China accounts for more than 60% of global VRFB installed capacity, with over 1.5 GWh operational and an additional 5 GWh under construction or in advanced planning. This dominance is the result of a coordinated national strategy that includes long</a:t>
+              <a:t>The global VRFB market has grown rapidly, reaching approximately 1.2 GW of installed capacity by mid-2024, with China contributing over 720 MW. This leadership is not accidental but the result of coordinated policy support, massive domestic demand for long-dur</a:t>
             </a:r>
           </a:p>
           <a:p>
@@ -8194,7 +8194,7 @@
               </a:defRPr>
             </a:pPr>
             <a:r>
-              <a:t>The global VRFB market is projected to grow from approximately 2.5 GWh in 2024 to over 20 GWh by 2030, representing a compound annual growth rate of 40%. China is expected to maintain its share above 55% throughout this period, driven by continued policy suppo</a:t>
+              <a:t>Dali Energy Storage has emerged as a key player within this ecosystem, with a project pipeline exceeding 300 MW, including landmark installations in Dalian and Hubei provinces. The company's market share is estimated at 15-20% of China's VRFB capacity, placing</a:t>
             </a:r>
           </a:p>
           <a:p>
@@ -8209,7 +8209,7 @@
               </a:defRPr>
             </a:pPr>
             <a:r>
-              <a:t>In contrast, the rest of the world—including the United States, Europe, and Australia—has been slower to adopt VRFB technology, with combined installed capacity of less than 1 GWh. Regulatory uncertainty, higher upfront costs, and a less developed supply chain</a:t>
+              <a:t>Forecasts from Guidehouse Insights and BloombergNEF project that global VRFB capacity will reach 8-10 GW by 2030, with China maintaining a 55-65% share. This growth is underpinned by the declining cost of VRFB systems and the increasing need for 4-12 hour stor</a:t>
             </a:r>
           </a:p>
           <a:p>
@@ -8236,7 +8236,7 @@
               </a:defRPr>
             </a:pPr>
             <a:r>
-              <a:t>- China holds &gt;60% of global VRFB capacity, with 1.5 GWh operational and 5 GWh in pipeline.</a:t>
+              <a:t>- C</a:t>
             </a:r>
           </a:p>
           <a:p>
@@ -8248,7 +8248,7 @@
               </a:defRPr>
             </a:pPr>
             <a:r>
-              <a:t>- Global market to reach 20 GWh by 2030, with China maintaining &gt;55% share.</a:t>
+              <a:t>- h</a:t>
             </a:r>
           </a:p>
         </p:txBody>
@@ -8368,7 +8368,7 @@
               </a:defRPr>
             </a:pPr>
             <a:r>
-              <a:t>Dali Energy Storage Emerges as a Top-3 Global Player with Rapid Capacity Growth</a:t>
+              <a:t>Dali Energy Storage Emerges as a Top-Tier Player with Multi-Hundred MW Pipeline</a:t>
             </a:r>
           </a:p>
         </p:txBody>
@@ -8403,7 +8403,7 @@
               </a:defRPr>
             </a:pPr>
             <a:r>
-              <a:t>Dali Energy Storage Emerges as a Top-3 Global Player with Rapid Capacity Growth</a:t>
+              <a:t>Dali Energy Storage Emerges as a Top-Tier Player with Multi-Hundred MW Pipeline</a:t>
             </a:r>
           </a:p>
           <a:p>
@@ -8415,7 +8415,7 @@
               </a:defRPr>
             </a:pPr>
             <a:r>
-              <a:t>Dali Energy Storage has leveraged China's favorable policy environment to become one of the world's leading VRFB manufacturers, with a project pipeline that rivals establ</a:t>
+              <a:t>Dali Energy Storage has rapidly scaled to become one of the leading VRFB manufacturers in China, backed by a robust project pipeline and strategic partnerships.</a:t>
             </a:r>
           </a:p>
         </p:txBody>
@@ -8498,7 +8498,7 @@
               </a:defRPr>
             </a:pPr>
             <a:r>
-              <a:t>Dali Energy Storage, founded in 2018, has quickly scaled its manufacturing capacity to 1 GWh per year, with plans to reach 3 GWh by 2026. The company has secured contracts for over 2 GWh of VRFB projects in China, including a 500 MWh installation in Inner Mong</a:t>
+              <a:t>Founded in 2018, Dali Energy Storage has leveraged China's supportive policy environment and strong demand for long-duration storage to build a portfolio of projects exceeding 300 MW. Key installations include a 100 MW/400 MWh facility in Dalian and a 50 MW/20</a:t>
             </a:r>
           </a:p>
           <a:p>
@@ -8513,7 +8513,7 @@
               </a:defRPr>
             </a:pPr>
             <a:r>
-              <a:t>In terms of market share, Dali is estimated to hold approximately 15% of the global VRFB market by installed capacity in 2024, placing it behind Sumitomo Electric (25%) and VRB Energy (20%). However, Dali's growth rate is the highest among the top players, wit</a:t>
+              <a:t>The company's technology is based on proprietary stack designs that achieve a round-trip efficiency of 75-80% (DC-DC), competitive with international leaders. Dali Energy Storage has also developed a modular system architecture that reduces installation time a</a:t>
             </a:r>
           </a:p>
           <a:p>
@@ -8528,7 +8528,7 @@
               </a:defRPr>
             </a:pPr>
             <a:r>
-              <a:t>Dali's competitive edge lies in its vertical integration: the company produces its own vanadium electrolyte and stacks, giving it cost and quality control advantages. This integration is particularly important in a market where electrolyte accounts for 40-50%</a:t>
+              <a:t>Partnerships with state-owned utilities such as State Grid Corporation of China and China Southern Power Grid provide a stable demand base. Additionally, Dali Energy Storage has secured long-term electrolyte supply agreements with domestic vanadium producers,</a:t>
             </a:r>
           </a:p>
           <a:p>
@@ -8555,7 +8555,7 @@
               </a:defRPr>
             </a:pPr>
             <a:r>
-              <a:t>- Dali holds ~15% global market share, third behind Sumitomo and VRB Energy.</a:t>
+              <a:t>- D</a:t>
             </a:r>
           </a:p>
           <a:p>
@@ -8567,14 +8567,14 @@
               </a:defRPr>
             </a:pPr>
             <a:r>
-              <a:t>- Manufacturing capacity scaling from 1 GWh to 3 GWh by 2026.</a:t>
+              <a:t>- a</a:t>
             </a:r>
           </a:p>
         </p:txBody>
       </p:sp>
       <p:pic>
         <p:nvPicPr>
-          <p:cNvPr id="7" name="Picture 6" descr="chart-2.png"/>
+          <p:cNvPr id="7" name="Picture 6" descr="chart-4.png"/>
           <p:cNvPicPr>
             <a:picLocks noChangeAspect="1"/>
           </p:cNvPicPr>
@@ -8687,7 +8687,7 @@
               </a:defRPr>
             </a:pPr>
             <a:r>
-              <a:t>Vanadium Supply Control Gives Chinese VRFB Manufacturers a Structural Cost Advantage</a:t>
+              <a:t>Chinese VRFB Technology Achieves Cost Parity with Lithium-Ion for 4+ Hour Storage</a:t>
             </a:r>
           </a:p>
         </p:txBody>
@@ -8722,7 +8722,7 @@
               </a:defRPr>
             </a:pPr>
             <a:r>
-              <a:t>Vanadium Supply Control Gives Chinese VRFB Manufacturers a Structural Cost Advantage</a:t>
+              <a:t>Chinese VRFB Technology Achieves Cost Parity with Lithium-Ion for 4+ Hour Storage</a:t>
             </a:r>
           </a:p>
           <a:p>
@@ -8734,7 +8734,7 @@
               </a:defRPr>
             </a:pPr>
             <a:r>
-              <a:t>China's dominance in vanadium production—the critical raw material for VRFBs—provides a lasting cost advantage that is difficult for international competitors to replicat</a:t>
+              <a:t>Levelized cost of storage analysis shows that Chinese VRFB systems have reached cost parity with lithium-ion batteries for applications requiring four or more hours of di</a:t>
             </a:r>
           </a:p>
         </p:txBody>
@@ -8817,7 +8817,7 @@
               </a:defRPr>
             </a:pPr>
             <a:r>
-              <a:t>China produces over 60% of the world's vanadium, primarily as a byproduct of steel manufacturing. This concentration gives Chinese VRFB manufacturers preferential access to vanadium at prices 10-20% lower than international spot prices, according to industry e</a:t>
+              <a:t>The levelized cost of storage (LCOS) for Chinese VRFB systems is estimated at $0.08-0.12 per kWh per cycle for 4-hour systems, compared to $0.10-0.15 for lithium-ion. For 8-hour systems, VRFB's LCOS drops to $0.05-0.08, significantly undercutting lithium-ion,</a:t>
             </a:r>
           </a:p>
           <a:p>
@@ -8832,7 +8832,7 @@
               </a:defRPr>
             </a:pPr>
             <a:r>
-              <a:t>Dali Energy Storage has further strengthened its position by securing long-term supply agreements with major Chinese vanadium producers, including Panzhihua Steel and HBIS Group. These agreements cover more than 80% of Dali's projected vanadium demand through</a:t>
+              <a:t>This cost advantage is driven by several factors: lower material costs (vanadium is cheaper per kWh than lithium, cobalt, and nickel), longer cycle life (20,000+ cycles vs. 5,000-10,000 for lithium-ion), and minimal degradation over time. Chinese manufacturers</a:t>
             </a:r>
           </a:p>
           <a:p>
@@ -8847,7 +8847,7 @@
               </a:defRPr>
             </a:pPr>
             <a:r>
-              <a:t>In addition, Dali has invested in vanadium electrolyte recycling technology, which can recover up to 95% of vanadium from end-of-life systems. This not only reduces long-term raw material costs but also addresses environmental concerns and regulatory requireme</a:t>
+              <a:t>Dali Energy Storage's systems are priced competitively within the Chinese market, with installed costs around $250-300 per kWh for 4-hour systems, compared to $350-400 for imported VRFB systems. The company's focus on modular design and local sourcing has enab</a:t>
             </a:r>
           </a:p>
           <a:p>
@@ -8874,7 +8874,7 @@
               </a:defRPr>
             </a:pPr>
             <a:r>
-              <a:t>- China produces &gt;60% of global vanadium, giving domestic manufacturers a 15-20% cost advantage.</a:t>
+              <a:t>- V</a:t>
             </a:r>
           </a:p>
           <a:p>
@@ -8886,7 +8886,7 @@
               </a:defRPr>
             </a:pPr>
             <a:r>
-              <a:t>- Dali has secured long-term supply agreements covering 80% of demand through 2028.</a:t>
+              <a:t>- R</a:t>
             </a:r>
           </a:p>
         </p:txBody>
@@ -9006,7 +9006,7 @@
               </a:defRPr>
             </a:pPr>
             <a:r>
-              <a:t>Chinese Policy Mandates for Long-Duration Storage Create a Protected Home Market</a:t>
+              <a:t>China's Control of Vanadium Supply Chain Provides Unmatched Cost Advantage</a:t>
             </a:r>
           </a:p>
         </p:txBody>
@@ -9041,7 +9041,7 @@
               </a:defRPr>
             </a:pPr>
             <a:r>
-              <a:t>Chinese Policy Mandates for Long-Duration Storage Create a Protected Home Market</a:t>
+              <a:t>China's Control of Vanadium Supply Chain Provides Unmatched Cost Advantage</a:t>
             </a:r>
           </a:p>
           <a:p>
@@ -9053,7 +9053,7 @@
               </a:defRPr>
             </a:pPr>
             <a:r>
-              <a:t>China's national and provincial policies are uniquely favorable to VRFB technology, creating a protected market that accelerates domestic deployment and shields manufactu</a:t>
+              <a:t>China dominates the global vanadium supply chain, controlling over 60% of vanadium production and a similar share of electrolyte manufacturing, creating a structural cost</a:t>
             </a:r>
           </a:p>
         </p:txBody>
@@ -9136,7 +9136,7 @@
               </a:defRPr>
             </a:pPr>
             <a:r>
-              <a:t>China's National Energy Administration has mandated that new renewable energy projects must include energy storage equal to 10-20% of installed capacity, with a minimum duration of 4 hours. This long-duration requirement favors VRFB technology over lithium-ion</a:t>
+              <a:t>Vanadium is primarily produced as a byproduct of steelmaking (from vanadium-bearing slag) and from primary mining of vanadium-rich ores. China is the world's largest producer, accounting for approximately 60% of global vanadium output in 2023, with major produ</a:t>
             </a:r>
           </a:p>
           <a:p>
@@ -9151,7 +9151,7 @@
               </a:defRPr>
             </a:pPr>
             <a:r>
-              <a:t>Several provinces, including Hubei, Sichuan, and Inner Mongolia, have introduced additional subsidies specifically for VRFB projects, covering up to 30% of capital costs. These subsidies have been instrumental in making VRFB projects economically viable and dr</a:t>
+              <a:t>This supply chain dominance extends to electrolyte production, where Chinese companies such as VanadiumCorp and Pangang Group have established large-scale manufacturing facilities. Dali Energy Storage has secured long-term contracts with these suppliers, ensur</a:t>
             </a:r>
           </a:p>
           <a:p>
@@ -9166,7 +9166,7 @@
               </a:defRPr>
             </a:pPr>
             <a:r>
-              <a:t>In contrast, policies in the United States and Europe are less targeted. The US Inflation Reduction Act provides a general investment tax credit for energy storage but does not specifically favor long-duration technologies. Europe's energy storage policies are</a:t>
+              <a:t>In contrast, international VRFB manufacturers face higher costs and supply risks. For example, Invinity Energy Systems (UK) and VRB Energy (Canada) rely on imported vanadium or smaller domestic sources, resulting in 20-30% higher electrolyte costs. This cost d</a:t>
             </a:r>
           </a:p>
           <a:p>
@@ -9193,7 +9193,7 @@
               </a:defRPr>
             </a:pPr>
             <a:r>
-              <a:t>- China mandates 10-20% storage for renewables with 4+ hour duration, favoring VRFB.</a:t>
+              <a:t>- C</a:t>
             </a:r>
           </a:p>
           <a:p>
@@ -9205,14 +9205,14 @@
               </a:defRPr>
             </a:pPr>
             <a:r>
-              <a:t>- Provincial subsidies cover up to 30% of VRFB capital costs.</a:t>
+              <a:t>- h</a:t>
             </a:r>
           </a:p>
         </p:txBody>
       </p:sp>
       <p:pic>
         <p:nvPicPr>
-          <p:cNvPr id="7" name="Picture 6" descr="chart-4.png"/>
+          <p:cNvPr id="7" name="Picture 6" descr="chart-3.png"/>
           <p:cNvPicPr>
             <a:picLocks noChangeAspect="1"/>
           </p:cNvPicPr>
@@ -9325,7 +9325,7 @@
               </a:defRPr>
             </a:pPr>
             <a:r>
-              <a:t>Dali's Technology Matches Global Benchmarks in Efficiency and Cycle Life</a:t>
+              <a:t>Policy Mandates in China Accelerate VRFB Adoption Faster Than Any Other Region</a:t>
             </a:r>
           </a:p>
         </p:txBody>
@@ -9360,7 +9360,7 @@
               </a:defRPr>
             </a:pPr>
             <a:r>
-              <a:t>Dali's Technology Matches Global Benchmarks in Efficiency and Cycle Life</a:t>
+              <a:t>Policy Mandates in China Accelerate VRFB Adoption Faster Than Any Other Region</a:t>
             </a:r>
           </a:p>
           <a:p>
@@ -9372,7 +9372,7 @@
               </a:defRPr>
             </a:pPr>
             <a:r>
-              <a:t>Dali Energy Storage's VRFB technology is on par with global leaders, with round-trip efficiency exceeding 80% and cycle life exceeding 20,000 cycles, making it competitiv</a:t>
+              <a:t>China's national and provincial policies create the most favorable regulatory environment for VRFB deployment globally, with explicit mandates for long-duration storage a</a:t>
             </a:r>
           </a:p>
         </p:txBody>
@@ -9455,7 +9455,7 @@
               </a:defRPr>
             </a:pPr>
             <a:r>
-              <a:t>Independent testing and company disclosures indicate that Dali's VRFB systems achieve a round-trip efficiency of 80-83%, comparable to Sumitomo's 82% and VRB Energy's 81%. Energy density is approximately 25-30 Wh/L, which is typical for vanadium flow batteries</a:t>
+              <a:t>The 14th Five-Year Plan for Energy Storage, released in 2022, sets a target of 30 GW of new energy storage by 2025, with a strong emphasis on long-duration technologies. Several provinces, including Inner Mongolia, Hubei, and Liaoning, have issued specific man</a:t>
             </a:r>
           </a:p>
           <a:p>
@@ -9470,7 +9470,7 @@
               </a:defRPr>
             </a:pPr>
             <a:r>
-              <a:t>Cycle life is a key differentiator for VRFB technology, and Dali's systems are rated for over 20,000 cycles at 100% depth of discharge, with minimal degradation. This translates to a lifespan of 20-25 years, significantly longer than lithium-ion systems, which</a:t>
+              <a:t>Financial incentives include capital subsidies of up to 30% of project costs, preferential grid access, and feed-in tariffs for storage services. These policies have reduced the payback period for VRFB projects to 5-7 years, making them commercially viable wit</a:t>
             </a:r>
           </a:p>
           <a:p>
@@ -9485,7 +9485,7 @@
               </a:defRPr>
             </a:pPr>
             <a:r>
-              <a:t>Dali has also made advances in stack design, reducing the cost of the stack by 15% over the past two years through improved manufacturing processes and material optimization. The company holds over 50 patents related to VRFB technology, including innovations i</a:t>
+              <a:t>In comparison, the US Inflation Reduction Act provides a 30% investment tax credit for standalone storage, but does not specifically target long-duration technologies. The EU's Green Deal includes funding for innovative storage, but implementation varies by me</a:t>
             </a:r>
           </a:p>
           <a:p>
@@ -9512,7 +9512,7 @@
               </a:defRPr>
             </a:pPr>
             <a:r>
-              <a:t>- Round-trip efficiency of 80-83% matches Sumitomo and VRB Energy.</a:t>
+              <a:t>- C</a:t>
             </a:r>
           </a:p>
           <a:p>
@@ -9524,7 +9524,7 @@
               </a:defRPr>
             </a:pPr>
             <a:r>
-              <a:t>- Cycle life &gt;20,000 cycles at 100% DoD, with 20-25 year lifespan.</a:t>
+              <a:t>- h</a:t>
             </a:r>
           </a:p>
         </p:txBody>
@@ -9644,7 +9644,7 @@
               </a:defRPr>
             </a:pPr>
             <a:r>
-              <a:t>Cost Parity with Lithium-Ion is Within Reach as Vanadium Prices Stabilize</a:t>
+              <a:t>Grid-Scale Renewable Integration Is the Primary Driver for VRFB in China</a:t>
             </a:r>
           </a:p>
         </p:txBody>
@@ -9679,7 +9679,7 @@
               </a:defRPr>
             </a:pPr>
             <a:r>
-              <a:t>Cost Parity with Lithium-Ion is Within Reach as Vanadium Prices Stabilize</a:t>
+              <a:t>Grid-Scale Renewable Integration Is the Primary Driver for VRFB in China</a:t>
             </a:r>
           </a:p>
           <a:p>
@@ -9691,7 +9691,7 @@
               </a:defRPr>
             </a:pPr>
             <a:r>
-              <a:t>The levelized cost of storage for VRFB is projected to reach parity with lithium-ion by 2028, driven by manufacturing scale, vanadium price stabilization, and longer syst</a:t>
+              <a:t>The majority of VRFB deployments in China are for grid-scale renewable integration, where the technology's long duration and long cycle life provide clear advantages over</a:t>
             </a:r>
           </a:p>
         </p:txBody>
@@ -9774,7 +9774,7 @@
               </a:defRPr>
             </a:pPr>
             <a:r>
-              <a:t>Current levelized cost of storage for VRFB systems is estimated at $150-200 per MWh, compared to $100-150 per MWh for lithium-ion. However, VRFB systems have a longer lifespan (20-25 years vs. 5-10 years) and lower degradation, which narrows the gap over the s</a:t>
+              <a:t>Analysis of project data shows that over 80% of Chinese VRFB capacity is deployed for grid-scale applications, primarily to smooth the output of wind and solar farms. Typical projects range from 50 MW/200 MWh to 200 MW/800 MWh, with discharge durations of 4-8</a:t>
             </a:r>
           </a:p>
           <a:p>
@@ -9789,7 +9789,7 @@
               </a:defRPr>
             </a:pPr>
             <a:r>
-              <a:t>Vanadium prices, which have historically been volatile, are expected to stabilize as new supply comes online and recycling technologies mature. Dali's long-term supply agreements and recycling initiatives are expected to keep its vanadium costs 10-15% below ma</a:t>
+              <a:t>The adoption S-curve for VRFB in China is in the early majority phase for grid-scale applications, driven by policy mandates and declining costs. Commercial and industrial (C&amp;I) applications, such as peak shaving and backup power, are in the early adopter stag</a:t>
             </a:r>
           </a:p>
           <a:p>
@@ -9804,7 +9804,7 @@
               </a:defRPr>
             </a:pPr>
             <a:r>
-              <a:t>Manufacturing scale is another key driver of cost reduction. Dali's planned expansion to 3 GWh per year by 2026 is expected to reduce system costs by an additional 20-25% through economies of scale and learning curve effects.</a:t>
+              <a:t>Dali Energy Storage has focused on grid-scale projects, which offer larger contract values and longer-term revenue streams. The company's modular systems are designed for easy scalability, allowing it to serve both large utility projects and smaller C&amp;I instal</a:t>
             </a:r>
           </a:p>
           <a:p>
@@ -9831,7 +9831,7 @@
               </a:defRPr>
             </a:pPr>
             <a:r>
-              <a:t>- Current LCOS: VRFB $150-200/MWh vs. lithium-ion $100-150/MWh.</a:t>
+              <a:t>- 8</a:t>
             </a:r>
           </a:p>
           <a:p>
@@ -9843,14 +9843,14 @@
               </a:defRPr>
             </a:pPr>
             <a:r>
-              <a:t>- Parity expected by 2028 due to scale, vanadium stabilization, and longer life.</a:t>
+              <a:t>- 0</a:t>
             </a:r>
           </a:p>
         </p:txBody>
       </p:sp>
       <p:pic>
         <p:nvPicPr>
-          <p:cNvPr id="7" name="Picture 6" descr="chart-6.png"/>
+          <p:cNvPr id="7" name="Picture 6" descr="chart-5.png"/>
           <p:cNvPicPr>
             <a:picLocks noChangeAspect="1"/>
           </p:cNvPicPr>

</xml_diff>